<commit_message>
actualización sesión 13 febrero
</commit_message>
<xml_diff>
--- a/Semana_0/Introducción.pptx
+++ b/Semana_0/Introducción.pptx
@@ -171,7 +171,7 @@
 <file path=ppt/revisionInfo.xml><?xml version="1.0" encoding="utf-8"?>
 <p1510:revInfo xmlns:a="http://schemas.openxmlformats.org/drawingml/2006/main" xmlns:r="http://schemas.openxmlformats.org/officeDocument/2006/relationships" xmlns:p1510="http://schemas.microsoft.com/office/powerpoint/2015/10/main">
   <p1510:revLst>
-    <p1510:client id="{8AC42068-6625-494F-B91D-97A1D33B96E2}" v="65" dt="2026-02-06T01:19:47.415"/>
+    <p1510:client id="{8AC42068-6625-494F-B91D-97A1D33B96E2}" v="69" dt="2026-02-07T00:27:53.163"/>
   </p1510:revLst>
 </p1510:revInfo>
 </file>
@@ -181,12 +181,12 @@
   <pc:docChgLst>
     <pc:chgData name="JHEYSON FABIAN VILLAVISAN BUITRAGO" userId="e5ced5c2-d787-455d-b115-4f08a699b8c8" providerId="ADAL" clId="{346ECE53-D0EE-4664-97A2-EE5ED4BD15CE}"/>
     <pc:docChg chg="undo custSel delSld modSld modSection">
-      <pc:chgData name="JHEYSON FABIAN VILLAVISAN BUITRAGO" userId="e5ced5c2-d787-455d-b115-4f08a699b8c8" providerId="ADAL" clId="{346ECE53-D0EE-4664-97A2-EE5ED4BD15CE}" dt="2026-02-06T01:19:47.415" v="330"/>
+      <pc:chgData name="JHEYSON FABIAN VILLAVISAN BUITRAGO" userId="e5ced5c2-d787-455d-b115-4f08a699b8c8" providerId="ADAL" clId="{346ECE53-D0EE-4664-97A2-EE5ED4BD15CE}" dt="2026-02-07T00:28:00.628" v="344" actId="478"/>
       <pc:docMkLst>
         <pc:docMk/>
       </pc:docMkLst>
       <pc:sldChg chg="addSp delSp modSp mod">
-        <pc:chgData name="JHEYSON FABIAN VILLAVISAN BUITRAGO" userId="e5ced5c2-d787-455d-b115-4f08a699b8c8" providerId="ADAL" clId="{346ECE53-D0EE-4664-97A2-EE5ED4BD15CE}" dt="2026-02-06T00:21:27.036" v="5"/>
+        <pc:chgData name="JHEYSON FABIAN VILLAVISAN BUITRAGO" userId="e5ced5c2-d787-455d-b115-4f08a699b8c8" providerId="ADAL" clId="{346ECE53-D0EE-4664-97A2-EE5ED4BD15CE}" dt="2026-02-07T00:28:00.628" v="344" actId="478"/>
         <pc:sldMkLst>
           <pc:docMk/>
           <pc:sldMk cId="0" sldId="256"/>
@@ -255,6 +255,14 @@
             <ac:picMk id="1028" creationId="{86BA1783-B2FE-6B6A-8793-A57527FC5C00}"/>
           </ac:picMkLst>
         </pc:picChg>
+        <pc:inkChg chg="add del">
+          <ac:chgData name="JHEYSON FABIAN VILLAVISAN BUITRAGO" userId="e5ced5c2-d787-455d-b115-4f08a699b8c8" providerId="ADAL" clId="{346ECE53-D0EE-4664-97A2-EE5ED4BD15CE}" dt="2026-02-07T00:28:00.628" v="344" actId="478"/>
+          <ac:inkMkLst>
+            <pc:docMk/>
+            <pc:sldMk cId="0" sldId="256"/>
+            <ac:inkMk id="2" creationId="{104657F6-69E4-1672-A2C2-647949C7FC64}"/>
+          </ac:inkMkLst>
+        </pc:inkChg>
       </pc:sldChg>
       <pc:sldChg chg="addSp delSp modSp mod">
         <pc:chgData name="JHEYSON FABIAN VILLAVISAN BUITRAGO" userId="e5ced5c2-d787-455d-b115-4f08a699b8c8" providerId="ADAL" clId="{346ECE53-D0EE-4664-97A2-EE5ED4BD15CE}" dt="2026-02-06T01:05:22.811" v="240" actId="2711"/>
@@ -762,7 +770,7 @@
         </pc:picChg>
       </pc:sldChg>
       <pc:sldChg chg="addSp delSp modSp mod">
-        <pc:chgData name="JHEYSON FABIAN VILLAVISAN BUITRAGO" userId="e5ced5c2-d787-455d-b115-4f08a699b8c8" providerId="ADAL" clId="{346ECE53-D0EE-4664-97A2-EE5ED4BD15CE}" dt="2026-02-06T01:19:27.386" v="324" actId="1076"/>
+        <pc:chgData name="JHEYSON FABIAN VILLAVISAN BUITRAGO" userId="e5ced5c2-d787-455d-b115-4f08a699b8c8" providerId="ADAL" clId="{346ECE53-D0EE-4664-97A2-EE5ED4BD15CE}" dt="2026-02-06T01:24:52.328" v="342" actId="1076"/>
         <pc:sldMkLst>
           <pc:docMk/>
           <pc:sldMk cId="1955606898" sldId="277"/>
@@ -781,6 +789,14 @@
             <pc:docMk/>
             <pc:sldMk cId="1955606898" sldId="277"/>
             <ac:spMk id="3" creationId="{67B35DA3-2B51-18DE-FA01-631BDA0B95F7}"/>
+          </ac:spMkLst>
+        </pc:spChg>
+        <pc:spChg chg="add mod">
+          <ac:chgData name="JHEYSON FABIAN VILLAVISAN BUITRAGO" userId="e5ced5c2-d787-455d-b115-4f08a699b8c8" providerId="ADAL" clId="{346ECE53-D0EE-4664-97A2-EE5ED4BD15CE}" dt="2026-02-06T01:24:52.328" v="342" actId="1076"/>
+          <ac:spMkLst>
+            <pc:docMk/>
+            <pc:sldMk cId="1955606898" sldId="277"/>
+            <ac:spMk id="4" creationId="{7530B2EE-9356-9A71-F076-D076DBE4F79F}"/>
           </ac:spMkLst>
         </pc:spChg>
         <pc:spChg chg="add del mod">
@@ -6903,7 +6919,7 @@
               <a:pPr>
                 <a:defRPr/>
               </a:pPr>
-              <a:t>5/02/2026</a:t>
+              <a:t>6/02/2026</a:t>
             </a:fld>
             <a:endParaRPr lang="es-CO"/>
           </a:p>
@@ -7146,7 +7162,7 @@
               <a:pPr>
                 <a:defRPr/>
               </a:pPr>
-              <a:t>5/02/2026</a:t>
+              <a:t>6/02/2026</a:t>
             </a:fld>
             <a:endParaRPr lang="es-CO"/>
           </a:p>
@@ -9971,7 +9987,7 @@
           <a:p>
             <a:fld id="{9CF7635E-2D71-42E7-9E6C-FBB85A15A85F}" type="datetimeFigureOut">
               <a:rPr lang="es-CO" smtClean="0"/>
-              <a:t>5/02/2026</a:t>
+              <a:t>6/02/2026</a:t>
             </a:fld>
             <a:endParaRPr lang="es-CO"/>
           </a:p>
@@ -10237,7 +10253,7 @@
           <a:p>
             <a:fld id="{9CF7635E-2D71-42E7-9E6C-FBB85A15A85F}" type="datetimeFigureOut">
               <a:rPr lang="es-CO" smtClean="0"/>
-              <a:t>5/02/2026</a:t>
+              <a:t>6/02/2026</a:t>
             </a:fld>
             <a:endParaRPr lang="es-CO"/>
           </a:p>
@@ -10453,7 +10469,7 @@
           <a:p>
             <a:fld id="{9CF7635E-2D71-42E7-9E6C-FBB85A15A85F}" type="datetimeFigureOut">
               <a:rPr lang="es-CO" smtClean="0"/>
-              <a:t>5/02/2026</a:t>
+              <a:t>6/02/2026</a:t>
             </a:fld>
             <a:endParaRPr lang="es-CO"/>
           </a:p>
@@ -12082,7 +12098,7 @@
           <a:p>
             <a:fld id="{9CF7635E-2D71-42E7-9E6C-FBB85A15A85F}" type="datetimeFigureOut">
               <a:rPr lang="es-CO" smtClean="0"/>
-              <a:t>5/02/2026</a:t>
+              <a:t>6/02/2026</a:t>
             </a:fld>
             <a:endParaRPr lang="es-CO"/>
           </a:p>
@@ -12529,7 +12545,7 @@
           <a:p>
             <a:fld id="{9CF7635E-2D71-42E7-9E6C-FBB85A15A85F}" type="datetimeFigureOut">
               <a:rPr lang="es-CO" smtClean="0"/>
-              <a:t>5/02/2026</a:t>
+              <a:t>6/02/2026</a:t>
             </a:fld>
             <a:endParaRPr lang="es-CO"/>
           </a:p>
@@ -12803,7 +12819,7 @@
           <a:p>
             <a:fld id="{9CF7635E-2D71-42E7-9E6C-FBB85A15A85F}" type="datetimeFigureOut">
               <a:rPr lang="es-CO" smtClean="0"/>
-              <a:t>5/02/2026</a:t>
+              <a:t>6/02/2026</a:t>
             </a:fld>
             <a:endParaRPr lang="es-CO"/>
           </a:p>
@@ -13224,7 +13240,7 @@
           <a:p>
             <a:fld id="{9CF7635E-2D71-42E7-9E6C-FBB85A15A85F}" type="datetimeFigureOut">
               <a:rPr lang="es-CO" smtClean="0"/>
-              <a:t>5/02/2026</a:t>
+              <a:t>6/02/2026</a:t>
             </a:fld>
             <a:endParaRPr lang="es-CO"/>
           </a:p>
@@ -13372,7 +13388,7 @@
           <a:p>
             <a:fld id="{9CF7635E-2D71-42E7-9E6C-FBB85A15A85F}" type="datetimeFigureOut">
               <a:rPr lang="es-CO" smtClean="0"/>
-              <a:t>5/02/2026</a:t>
+              <a:t>6/02/2026</a:t>
             </a:fld>
             <a:endParaRPr lang="es-CO"/>
           </a:p>
@@ -13491,7 +13507,7 @@
           <a:p>
             <a:fld id="{9CF7635E-2D71-42E7-9E6C-FBB85A15A85F}" type="datetimeFigureOut">
               <a:rPr lang="es-CO" smtClean="0"/>
-              <a:t>5/02/2026</a:t>
+              <a:t>6/02/2026</a:t>
             </a:fld>
             <a:endParaRPr lang="es-CO"/>
           </a:p>
@@ -13810,7 +13826,7 @@
           <a:p>
             <a:fld id="{9CF7635E-2D71-42E7-9E6C-FBB85A15A85F}" type="datetimeFigureOut">
               <a:rPr lang="es-CO" smtClean="0"/>
-              <a:t>5/02/2026</a:t>
+              <a:t>6/02/2026</a:t>
             </a:fld>
             <a:endParaRPr lang="es-CO"/>
           </a:p>
@@ -14105,7 +14121,7 @@
           <a:p>
             <a:fld id="{9CF7635E-2D71-42E7-9E6C-FBB85A15A85F}" type="datetimeFigureOut">
               <a:rPr lang="es-CO" smtClean="0"/>
-              <a:t>5/02/2026</a:t>
+              <a:t>6/02/2026</a:t>
             </a:fld>
             <a:endParaRPr lang="es-CO"/>
           </a:p>
@@ -14354,7 +14370,7 @@
           <a:p>
             <a:fld id="{9CF7635E-2D71-42E7-9E6C-FBB85A15A85F}" type="datetimeFigureOut">
               <a:rPr lang="es-CO" smtClean="0"/>
-              <a:t>5/02/2026</a:t>
+              <a:t>6/02/2026</a:t>
             </a:fld>
             <a:endParaRPr lang="es-CO"/>
           </a:p>
@@ -22772,6 +22788,47 @@
           </a:extLst>
         </p:spPr>
       </p:pic>
+      <p:sp>
+        <p:nvSpPr>
+          <p:cNvPr id="4" name="CuadroTexto 3">
+            <a:extLst>
+              <a:ext uri="{FF2B5EF4-FFF2-40B4-BE49-F238E27FC236}">
+                <a16:creationId xmlns:a16="http://schemas.microsoft.com/office/drawing/2014/main" id="{7530B2EE-9356-9A71-F076-D076DBE4F79F}"/>
+              </a:ext>
+            </a:extLst>
+          </p:cNvPr>
+          <p:cNvSpPr txBox="1"/>
+          <p:nvPr/>
+        </p:nvSpPr>
+        <p:spPr>
+          <a:xfrm>
+            <a:off x="1974690" y="4941168"/>
+            <a:ext cx="5502596" cy="369332"/>
+          </a:xfrm>
+          <a:prstGeom prst="rect">
+            <a:avLst/>
+          </a:prstGeom>
+          <a:noFill/>
+        </p:spPr>
+        <p:txBody>
+          <a:bodyPr wrap="square">
+            <a:spAutoFit/>
+          </a:bodyPr>
+          <a:lstStyle/>
+          <a:p>
+            <a:r>
+              <a:rPr lang="es-CO" dirty="0">
+                <a:hlinkClick r:id="rId10"/>
+              </a:rPr>
+              <a:t>https://github.com/F4bian1012/ProyectoInvestigacionIV</a:t>
+            </a:r>
+            <a:r>
+              <a:rPr lang="es-CO" dirty="0"/>
+              <a:t> </a:t>
+            </a:r>
+          </a:p>
+        </p:txBody>
+      </p:sp>
     </p:spTree>
     <p:extLst>
       <p:ext uri="{BB962C8B-B14F-4D97-AF65-F5344CB8AC3E}">

</xml_diff>